<commit_message>
Remove retired swap reference and publish current Mandate product scope
</commit_message>
<xml_diff>
--- a/competition/submission-2026-10-20/presentation/mandate-wallet-10min-final.pptx
+++ b/competition/submission-2026-10-20/presentation/mandate-wallet-10min-final.pptx
@@ -1855,7 +1855,7 @@
           <a:lstStyle xmlns:a="http://schemas.openxmlformats.org/drawingml/2006/main"/>
           <a:p xmlns:a="http://schemas.openxmlformats.org/drawingml/2006/main">
             <a:r>
-              <a:t>The earlier proposal asks how approved intent binds to an action, what evidence supports delegated-session accountability, and what remains observable when a host interferes. Mandate answers the first question with typed payment registration and shared reservations. Signed checkpoints, selective disclosures and ActionProof address the second. A reference controller and retained-head comparisons test a bounded part of the third. Echo supplies a separate repaired UserOperation and swap reference. The contribution is this implemented combination and its failure analysis. Scoped wallets already exist, and the current release covers only part of the proposal’s broader research agenda.</a:t>
+              <a:t>The earlier proposal asks how approved intent binds to an action, what evidence supports delegated-session accountability, and what remains observable when a host interferes. Mandate answers the first question with typed payment registration and shared reservations. Signed checkpoints, selective disclosures and ActionProof address the second. A reference controller and retained-head comparisons test a bounded part of the third. The research contribution connects finite on-chain permissions to purchase evidence and tests the limits under concurrent requests, failed delivery and hostile host behavior. Scoped wallets already exist, and the current release covers only part of the proposal’s broader research agenda.</a:t>
             </a:r>
           </a:p>
           <a:p xmlns:a="http://schemas.openxmlformats.org/drawingml/2006/main">
@@ -1870,7 +1870,7 @@
           </a:p>
           <a:p xmlns:a="http://schemas.openxmlformats.org/drawingml/2006/main">
             <a:r>
-              <a:t>Chinese presenter direction (not spoken): 三项研究问题分别对应授权约束、会话证据和宿主干预。说明 Echo 的基础作用与 Mandate 的新增实现，不把整个 proposal 的研究目标表述为既有成果。</a:t>
+              <a:t>Chinese presenter direction (not spoken): 三项研究问题分别对应授权约束、会话证据和宿主干预。结合实现说明研究贡献，并区分已验证的机制与尚待完成的研究目标。</a:t>
             </a:r>
           </a:p>
           <a:p xmlns:a="http://schemas.openxmlformats.org/drawingml/2006/main">
@@ -4871,199 +4871,199 @@
 </file>
 
 <file path=ppt/slides/charts/chart1.xml><?xml version="1.0" encoding="utf-8"?>
-<c:chartSpace xmlns:c="http://schemas.openxmlformats.org/drawingml/2006/chart" xmlns:r="http://schemas.openxmlformats.org/officeDocument/2006/relationships">
-  <c:lang val="en-US"/>
-  <c:chart>
-    <c:plotArea>
-      <c:barChart>
-        <c:barDir val="col"/>
-        <c:grouping val="clustered"/>
-        <c:varyColors val="0"/>
-        <c:ser>
-          <c:idx val="0"/>
-          <c:order val="0"/>
-          <c:tx>
-            <c:v>Milliseconds</c:v>
-          </c:tx>
-          <c:spPr>
-            <a:solidFill xmlns:a="http://schemas.openxmlformats.org/drawingml/2006/main">
-              <a:srgbClr val="62ACFF"/>
-            </a:solidFill>
-          </c:spPr>
-          <c:invertIfNegative val="0"/>
-          <c:cat>
-            <c:strRef>
-              <c:f>'Chart Data'!$A$2:$A$5</c:f>
-              <c:strCache>
-                <c:ptCount val="4"/>
-                <c:pt idx="0">
-                  <c:v>EOA reference</c:v>
-                </c:pt>
-                <c:pt idx="1">
-                  <c:v>Mandate</c:v>
-                </c:pt>
-                <c:pt idx="2">
-                  <c:v>+ evidence</c:v>
-                </c:pt>
-                <c:pt idx="3">
-                  <c:v>+ controller</c:v>
-                </c:pt>
-              </c:strCache>
-            </c:strRef>
-          </c:cat>
-          <c:val>
-            <c:numRef>
-              <c:f>'Chart Data'!$B$2:$B$5</c:f>
-              <c:numCache>
-                <c:formatCode>General</c:formatCode>
-                <c:ptCount val="4"/>
-                <c:pt idx="0">
-                  <c:v>27.33</c:v>
-                </c:pt>
-                <c:pt idx="1">
-                  <c:v>55.72</c:v>
-                </c:pt>
-                <c:pt idx="2">
-                  <c:v>317.94</c:v>
-                </c:pt>
-                <c:pt idx="3">
-                  <c:v>399.33</c:v>
-                </c:pt>
-              </c:numCache>
-            </c:numRef>
-          </c:val>
-        </c:ser>
-        <c:dLbls>
-          <c:numFmt formatCode="0.00" sourceLinked="0"/>
-          <c:txPr>
-            <a:bodyPr xmlns:a="http://schemas.openxmlformats.org/drawingml/2006/main" anchorCtr="1"/>
-            <a:lstStyle xmlns:a="http://schemas.openxmlformats.org/drawingml/2006/main"/>
-            <a:p xmlns:a="http://schemas.openxmlformats.org/drawingml/2006/main">
-              <a:pPr>
-                <a:defRPr sz="1575">
-                  <a:solidFill>
-                    <a:srgbClr val="F5F6F8"/>
-                  </a:solidFill>
-                  <a:latin typeface="Arial"/>
-                  <a:ea typeface="Arial"/>
-                  <a:cs typeface="Arial"/>
-                </a:defRPr>
-              </a:pPr>
-            </a:p>
-          </c:txPr>
-          <c:dLblPos val="outEnd"/>
-          <c:showLegendKey val="0"/>
-          <c:showVal val="1"/>
-          <c:showCatName val="0"/>
-          <c:showSerName val="0"/>
-          <c:showPercent val="0"/>
-          <c:showBubbleSize val="0"/>
-          <c:showLeaderLines val="0"/>
-        </c:dLbls>
-        <c:gapWidth val="100"/>
-        <c:axId val="48650112"/>
-        <c:axId val="48672768"/>
-      </c:barChart>
-      <c:catAx>
-        <c:axId val="48650112"/>
-        <c:scaling>
-          <c:orientation val="minMax"/>
-        </c:scaling>
-        <c:delete val="0"/>
-        <c:axPos val="b"/>
-        <c:numFmt formatCode="General"/>
-        <c:majorTickMark val="none"/>
-        <c:minorTickMark val="none"/>
-        <c:spPr>
-          <a:ln xmlns:a="http://schemas.openxmlformats.org/drawingml/2006/main" w="9525">
-            <a:solidFill>
-              <a:srgbClr val="354052"/>
-            </a:solidFill>
-          </a:ln>
-        </c:spPr>
-        <c:txPr>
-          <a:bodyPr xmlns:a="http://schemas.openxmlformats.org/drawingml/2006/main" anchorCtr="1"/>
-          <a:lstStyle xmlns:a="http://schemas.openxmlformats.org/drawingml/2006/main"/>
-          <a:p xmlns:a="http://schemas.openxmlformats.org/drawingml/2006/main">
-            <a:pPr>
-              <a:defRPr sz="1425">
-                <a:solidFill>
-                  <a:srgbClr val="F5F6F8"/>
-                </a:solidFill>
-                <a:latin typeface="Arial"/>
-                <a:ea typeface="Arial"/>
-                <a:cs typeface="Arial"/>
-              </a:defRPr>
-            </a:pPr>
-          </a:p>
-        </c:txPr>
-        <c:crossAx val="48672768"/>
-      </c:catAx>
-      <c:valAx>
-        <c:axId val="48672768"/>
-        <c:scaling>
-          <c:orientation val="minMax"/>
-          <c:max val="450"/>
-          <c:min val="0"/>
-        </c:scaling>
-        <c:delete val="0"/>
-        <c:axPos val="l"/>
-        <c:majorGridlines>
-          <c:spPr>
-            <a:ln xmlns:a="http://schemas.openxmlformats.org/drawingml/2006/main" w="9525">
-              <a:solidFill>
-                <a:srgbClr val="354052"/>
-              </a:solidFill>
-            </a:ln>
-          </c:spPr>
-        </c:majorGridlines>
-        <c:numFmt formatCode="General"/>
-        <c:majorTickMark val="none"/>
-        <c:minorTickMark val="none"/>
-        <c:spPr>
-          <a:ln xmlns:a="http://schemas.openxmlformats.org/drawingml/2006/main" w="9525">
-            <a:solidFill>
-              <a:srgbClr val="D4D4D4"/>
-            </a:solidFill>
-            <a:prstDash val="solid"/>
-          </a:ln>
-        </c:spPr>
-        <c:txPr>
-          <a:bodyPr xmlns:a="http://schemas.openxmlformats.org/drawingml/2006/main" anchorCtr="1"/>
-          <a:lstStyle xmlns:a="http://schemas.openxmlformats.org/drawingml/2006/main"/>
-          <a:p xmlns:a="http://schemas.openxmlformats.org/drawingml/2006/main">
-            <a:pPr>
-              <a:defRPr sz="1500">
-                <a:solidFill>
-                  <a:srgbClr val="A0A5AF"/>
-                </a:solidFill>
-                <a:latin typeface="Arial"/>
-                <a:ea typeface="Arial"/>
-                <a:cs typeface="Arial"/>
-              </a:defRPr>
-            </a:pPr>
-          </a:p>
-        </c:txPr>
-        <c:crossAx val="48650112"/>
-        <c:crossBetween val="between"/>
-      </c:valAx>
-      <c:spPr>
-        <a:solidFill xmlns:a="http://schemas.openxmlformats.org/drawingml/2006/main">
-          <a:srgbClr val="08090B"/>
-        </a:solidFill>
-      </c:spPr>
-    </c:plotArea>
-    <c:plotVisOnly val="1"/>
-  </c:chart>
-  <c:spPr>
-    <a:solidFill xmlns:a="http://schemas.openxmlformats.org/drawingml/2006/main">
-      <a:srgbClr val="08090B"/>
-    </a:solidFill>
-  </c:spPr>
-  <c:externalData r:id="rIdChartSnapshot1">
-    <c:autoUpdate val="0"/>
-  </c:externalData>
-</c:chartSpace>
+<ns0:chartSpace xmlns:ns0="http://schemas.openxmlformats.org/drawingml/2006/chart" xmlns:ns1="http://schemas.openxmlformats.org/drawingml/2006/main" xmlns:ns2="http://schemas.openxmlformats.org/officeDocument/2006/relationships">
+  <ns0:lang val="en-US"/>
+  <ns0:chart>
+    <ns0:plotArea>
+      <ns0:barChart>
+        <ns0:barDir val="col"/>
+        <ns0:grouping val="clustered"/>
+        <ns0:varyColors val="0"/>
+        <ns0:ser>
+          <ns0:idx val="0"/>
+          <ns0:order val="0"/>
+          <ns0:tx>
+            <ns0:v>Milliseconds</ns0:v>
+          </ns0:tx>
+          <ns0:spPr>
+            <ns1:solidFill>
+              <ns1:srgbClr val="62ACFF"/>
+            </ns1:solidFill>
+          </ns0:spPr>
+          <ns0:invertIfNegative val="0"/>
+          <ns0:cat>
+            <ns0:strRef>
+              <ns0:f>'Chart Data'!$A$2:$A$5</ns0:f>
+              <ns0:strCache>
+                <ns0:ptCount val="4"/>
+                <ns0:pt idx="0">
+                  <ns0:v>EOA reference</ns0:v>
+                </ns0:pt>
+                <ns0:pt idx="1">
+                  <ns0:v>Mandate</ns0:v>
+                </ns0:pt>
+                <ns0:pt idx="2">
+                  <ns0:v>+ evidence</ns0:v>
+                </ns0:pt>
+                <ns0:pt idx="3">
+                  <ns0:v>+ controller</ns0:v>
+                </ns0:pt>
+              </ns0:strCache>
+            </ns0:strRef>
+          </ns0:cat>
+          <ns0:val>
+            <ns0:numRef>
+              <ns0:f>'Chart Data'!$B$2:$B$5</ns0:f>
+              <ns0:numCache>
+                <ns0:formatCode>General</ns0:formatCode>
+                <ns0:ptCount val="4"/>
+                <ns0:pt idx="0">
+                  <ns0:v>28.02</ns0:v>
+                </ns0:pt>
+                <ns0:pt idx="1">
+                  <ns0:v>59.36</ns0:v>
+                </ns0:pt>
+                <ns0:pt idx="2">
+                  <ns0:v>337.25</ns0:v>
+                </ns0:pt>
+                <ns0:pt idx="3">
+                  <ns0:v>416.55</ns0:v>
+                </ns0:pt>
+              </ns0:numCache>
+            </ns0:numRef>
+          </ns0:val>
+        </ns0:ser>
+        <ns0:dLbls>
+          <ns0:numFmt formatCode="0.00" sourceLinked="0"/>
+          <ns0:txPr>
+            <ns1:bodyPr anchorCtr="1"/>
+            <ns1:lstStyle/>
+            <ns1:p>
+              <ns1:pPr>
+                <ns1:defRPr sz="1575">
+                  <ns1:solidFill>
+                    <ns1:srgbClr val="F5F6F8"/>
+                  </ns1:solidFill>
+                  <ns1:latin typeface="Arial"/>
+                  <ns1:ea typeface="Arial"/>
+                  <ns1:cs typeface="Arial"/>
+                </ns1:defRPr>
+              </ns1:pPr>
+            </ns1:p>
+          </ns0:txPr>
+          <ns0:dLblPos val="outEnd"/>
+          <ns0:showLegendKey val="0"/>
+          <ns0:showVal val="1"/>
+          <ns0:showCatName val="0"/>
+          <ns0:showSerName val="0"/>
+          <ns0:showPercent val="0"/>
+          <ns0:showBubbleSize val="0"/>
+          <ns0:showLeaderLines val="0"/>
+        </ns0:dLbls>
+        <ns0:gapWidth val="100"/>
+        <ns0:axId val="48650112"/>
+        <ns0:axId val="48672768"/>
+      </ns0:barChart>
+      <ns0:catAx>
+        <ns0:axId val="48650112"/>
+        <ns0:scaling>
+          <ns0:orientation val="minMax"/>
+        </ns0:scaling>
+        <ns0:delete val="0"/>
+        <ns0:axPos val="b"/>
+        <ns0:numFmt formatCode="General"/>
+        <ns0:majorTickMark val="none"/>
+        <ns0:minorTickMark val="none"/>
+        <ns0:spPr>
+          <ns1:ln w="9525">
+            <ns1:solidFill>
+              <ns1:srgbClr val="354052"/>
+            </ns1:solidFill>
+          </ns1:ln>
+        </ns0:spPr>
+        <ns0:txPr>
+          <ns1:bodyPr anchorCtr="1"/>
+          <ns1:lstStyle/>
+          <ns1:p>
+            <ns1:pPr>
+              <ns1:defRPr sz="1425">
+                <ns1:solidFill>
+                  <ns1:srgbClr val="F5F6F8"/>
+                </ns1:solidFill>
+                <ns1:latin typeface="Arial"/>
+                <ns1:ea typeface="Arial"/>
+                <ns1:cs typeface="Arial"/>
+              </ns1:defRPr>
+            </ns1:pPr>
+          </ns1:p>
+        </ns0:txPr>
+        <ns0:crossAx val="48672768"/>
+      </ns0:catAx>
+      <ns0:valAx>
+        <ns0:axId val="48672768"/>
+        <ns0:scaling>
+          <ns0:orientation val="minMax"/>
+          <ns0:max val="450"/>
+          <ns0:min val="0"/>
+        </ns0:scaling>
+        <ns0:delete val="0"/>
+        <ns0:axPos val="l"/>
+        <ns0:majorGridlines>
+          <ns0:spPr>
+            <ns1:ln w="9525">
+              <ns1:solidFill>
+                <ns1:srgbClr val="354052"/>
+              </ns1:solidFill>
+            </ns1:ln>
+          </ns0:spPr>
+        </ns0:majorGridlines>
+        <ns0:numFmt formatCode="General"/>
+        <ns0:majorTickMark val="none"/>
+        <ns0:minorTickMark val="none"/>
+        <ns0:spPr>
+          <ns1:ln w="9525">
+            <ns1:solidFill>
+              <ns1:srgbClr val="D4D4D4"/>
+            </ns1:solidFill>
+            <ns1:prstDash val="solid"/>
+          </ns1:ln>
+        </ns0:spPr>
+        <ns0:txPr>
+          <ns1:bodyPr anchorCtr="1"/>
+          <ns1:lstStyle/>
+          <ns1:p>
+            <ns1:pPr>
+              <ns1:defRPr sz="1500">
+                <ns1:solidFill>
+                  <ns1:srgbClr val="A0A5AF"/>
+                </ns1:solidFill>
+                <ns1:latin typeface="Arial"/>
+                <ns1:ea typeface="Arial"/>
+                <ns1:cs typeface="Arial"/>
+              </ns1:defRPr>
+            </ns1:pPr>
+          </ns1:p>
+        </ns0:txPr>
+        <ns0:crossAx val="48650112"/>
+        <ns0:crossBetween val="between"/>
+      </ns0:valAx>
+      <ns0:spPr>
+        <ns1:solidFill>
+          <ns1:srgbClr val="08090B"/>
+        </ns1:solidFill>
+      </ns0:spPr>
+    </ns0:plotArea>
+    <ns0:plotVisOnly val="1"/>
+  </ns0:chart>
+  <ns0:spPr>
+    <ns1:solidFill>
+      <ns1:srgbClr val="08090B"/>
+    </ns1:solidFill>
+  </ns0:spPr>
+  <ns0:externalData ns2:id="rIdChartSnapshot1">
+    <ns0:autoUpdate val="0"/>
+  </ns0:externalData>
+</ns0:chartSpace>
 </file>
 
 <file path=ppt/slides/slide1.xml><?xml version="1.0" encoding="utf-8"?>

</xml_diff>